<commit_message>
Update presentation in docs
</commit_message>
<xml_diff>
--- a/docs/PRESENTATION.pptx
+++ b/docs/PRESENTATION.pptx
@@ -683,7 +683,7 @@
                 <a:tab pos="0" algn="l"/>
               </a:tabLst>
             </a:pPr>
-            <a:fld id="{C53AFBFA-81F8-4429-B7DF-69E440B319AC}" type="slidenum">
+            <a:fld id="{BE86D276-FB75-40A9-B59A-DF2DEEF3D9E2}" type="slidenum">
               <a:rPr lang="en-US" sz="1400" b="0" u="none" strike="noStrike">
                 <a:solidFill>
                   <a:srgbClr val="000000"/>
@@ -1008,7 +1008,7 @@
                 <a:tab pos="0" algn="l"/>
               </a:tabLst>
             </a:pPr>
-            <a:fld id="{B0AAC3CE-35B9-446D-8D7E-02311443CCE6}" type="slidenum">
+            <a:fld id="{9E63502E-9B73-42C9-B4DE-87EE663C803B}" type="slidenum">
               <a:rPr lang="en-US" sz="1400" b="0" u="none" strike="noStrike">
                 <a:solidFill>
                   <a:srgbClr val="000000"/>
@@ -2007,7 +2007,7 @@
                 <a:uFillTx/>
                 <a:latin typeface="Calibri"/>
               </a:rPr>
-              <a:t>База данных</a:t>
+              <a:t>Тестирование</a:t>
             </a:r>
             <a:endParaRPr lang="en-US" sz="4400" b="0" u="none" strike="noStrike">
               <a:solidFill>
@@ -2032,8 +2032,8 @@
         </p:blipFill>
         <p:spPr>
           <a:xfrm>
-            <a:off x="457200" y="1828800"/>
-            <a:ext cx="9463680" cy="2022840"/>
+            <a:off x="3429720" y="2057400"/>
+            <a:ext cx="2902320" cy="1919880"/>
           </a:xfrm>
           <a:prstGeom prst="rect">
             <a:avLst/>
@@ -2056,8 +2056,8 @@
         </p:blipFill>
         <p:spPr>
           <a:xfrm>
-            <a:off x="457200" y="4115520"/>
-            <a:ext cx="9373680" cy="862560"/>
+            <a:off x="228600" y="2057400"/>
+            <a:ext cx="2971440" cy="1925640"/>
           </a:xfrm>
           <a:prstGeom prst="rect">
             <a:avLst/>
@@ -2068,6 +2068,96 @@
           </a:ln>
         </p:spPr>
       </p:pic>
+      <p:pic>
+        <p:nvPicPr>
+          <p:cNvPr id="50" name=""/>
+          <p:cNvPicPr/>
+          <p:nvPr/>
+        </p:nvPicPr>
+        <p:blipFill>
+          <a:blip r:embed="rId3"/>
+          <a:stretch/>
+        </p:blipFill>
+        <p:spPr>
+          <a:xfrm>
+            <a:off x="6630120" y="2057400"/>
+            <a:ext cx="2993760" cy="1914120"/>
+          </a:xfrm>
+          <a:prstGeom prst="rect">
+            <a:avLst/>
+          </a:prstGeom>
+          <a:noFill/>
+          <a:ln w="38160">
+            <a:noFill/>
+          </a:ln>
+        </p:spPr>
+      </p:pic>
+      <p:sp>
+        <p:nvSpPr>
+          <p:cNvPr id="51" name=""/>
+          <p:cNvSpPr/>
+          <p:nvPr/>
+        </p:nvSpPr>
+        <p:spPr>
+          <a:xfrm>
+            <a:off x="457200" y="4344120"/>
+            <a:ext cx="9030600" cy="685440"/>
+          </a:xfrm>
+          <a:prstGeom prst="rect">
+            <a:avLst/>
+          </a:prstGeom>
+          <a:noFill/>
+          <a:ln w="0">
+            <a:noFill/>
+          </a:ln>
+        </p:spPr>
+        <p:style>
+          <a:lnRef idx="0"/>
+          <a:fillRef idx="0"/>
+          <a:effectRef idx="0"/>
+          <a:fontRef idx="minor"/>
+        </p:style>
+        <p:txBody>
+          <a:bodyPr lIns="0" tIns="0" rIns="0" bIns="0" anchor="t">
+            <a:normAutofit/>
+          </a:bodyPr>
+          <a:p>
+            <a:pPr marL="432000" indent="-324000">
+              <a:lnSpc>
+                <a:spcPct val="100000"/>
+              </a:lnSpc>
+              <a:spcBef>
+                <a:spcPts val="1417"/>
+              </a:spcBef>
+              <a:buClr>
+                <a:srgbClr val="000000"/>
+              </a:buClr>
+              <a:buSzPct val="45000"/>
+              <a:buFont typeface="Wingdings" charset="2"/>
+              <a:buChar char=""/>
+            </a:pPr>
+            <a:r>
+              <a:rPr lang="en-US" sz="2200" b="0" u="none" strike="noStrike">
+                <a:solidFill>
+                  <a:srgbClr val="000000"/>
+                </a:solidFill>
+                <a:effectLst/>
+                <a:uFillTx/>
+                <a:latin typeface="Calibri"/>
+              </a:rPr>
+              <a:t>86 тестов – 86 успешно</a:t>
+            </a:r>
+            <a:endParaRPr lang="en-US" sz="2200" b="0" u="none" strike="noStrike">
+              <a:solidFill>
+                <a:srgbClr val="FFFFFF"/>
+              </a:solidFill>
+              <a:effectLst/>
+              <a:uFillTx/>
+              <a:latin typeface="Calibri"/>
+            </a:endParaRPr>
+          </a:p>
+        </p:txBody>
+      </p:sp>
     </p:spTree>
   </p:cSld>
   <mc:AlternateContent>
@@ -2100,7 +2190,7 @@
       </p:grpSpPr>
       <p:sp>
         <p:nvSpPr>
-          <p:cNvPr id="50" name="PlaceHolder 1"/>
+          <p:cNvPr id="52" name="PlaceHolder 1"/>
           <p:cNvSpPr>
             <a:spLocks noGrp="1"/>
           </p:cNvSpPr>
@@ -2144,7 +2234,7 @@
                 <a:uFillTx/>
                 <a:latin typeface="Calibri"/>
               </a:rPr>
-              <a:t>Тестирование</a:t>
+              <a:t>Ссылки</a:t>
             </a:r>
             <a:endParaRPr lang="en-US" sz="4400" b="0" u="none" strike="noStrike">
               <a:solidFill>
@@ -2157,88 +2247,20 @@
           </a:p>
         </p:txBody>
       </p:sp>
-      <p:pic>
-        <p:nvPicPr>
-          <p:cNvPr id="51" name=""/>
-          <p:cNvPicPr/>
-          <p:nvPr/>
-        </p:nvPicPr>
-        <p:blipFill>
-          <a:blip r:embed="rId1"/>
-          <a:stretch/>
-        </p:blipFill>
-        <p:spPr>
-          <a:xfrm>
-            <a:off x="3429720" y="2057400"/>
-            <a:ext cx="2902320" cy="1919880"/>
-          </a:xfrm>
-          <a:prstGeom prst="rect">
-            <a:avLst/>
-          </a:prstGeom>
-          <a:noFill/>
-          <a:ln w="38160">
-            <a:noFill/>
-          </a:ln>
-        </p:spPr>
-      </p:pic>
-      <p:pic>
-        <p:nvPicPr>
-          <p:cNvPr id="52" name=""/>
-          <p:cNvPicPr/>
-          <p:nvPr/>
-        </p:nvPicPr>
-        <p:blipFill>
-          <a:blip r:embed="rId2"/>
-          <a:stretch/>
-        </p:blipFill>
-        <p:spPr>
-          <a:xfrm>
-            <a:off x="228600" y="2057400"/>
-            <a:ext cx="2971440" cy="1925640"/>
-          </a:xfrm>
-          <a:prstGeom prst="rect">
-            <a:avLst/>
-          </a:prstGeom>
-          <a:noFill/>
-          <a:ln w="38160">
-            <a:noFill/>
-          </a:ln>
-        </p:spPr>
-      </p:pic>
-      <p:pic>
-        <p:nvPicPr>
-          <p:cNvPr id="53" name=""/>
-          <p:cNvPicPr/>
-          <p:nvPr/>
-        </p:nvPicPr>
-        <p:blipFill>
-          <a:blip r:embed="rId3"/>
-          <a:stretch/>
-        </p:blipFill>
-        <p:spPr>
-          <a:xfrm>
-            <a:off x="6630120" y="2057400"/>
-            <a:ext cx="2993760" cy="1914120"/>
-          </a:xfrm>
-          <a:prstGeom prst="rect">
-            <a:avLst/>
-          </a:prstGeom>
-          <a:noFill/>
-          <a:ln w="38160">
-            <a:noFill/>
-          </a:ln>
-        </p:spPr>
-      </p:pic>
       <p:sp>
         <p:nvSpPr>
-          <p:cNvPr id="54" name=""/>
-          <p:cNvSpPr/>
-          <p:nvPr/>
+          <p:cNvPr id="53" name="PlaceHolder 2"/>
+          <p:cNvSpPr>
+            <a:spLocks noGrp="1"/>
+          </p:cNvSpPr>
+          <p:nvPr>
+            <p:ph/>
+          </p:nvPr>
         </p:nvSpPr>
         <p:spPr>
           <a:xfrm>
-            <a:off x="457200" y="4344120"/>
-            <a:ext cx="9030600" cy="685440"/>
+            <a:off x="264600" y="1636200"/>
+            <a:ext cx="9071280" cy="3287880"/>
           </a:xfrm>
           <a:prstGeom prst="rect">
             <a:avLst/>
@@ -2248,20 +2270,14 @@
             <a:noFill/>
           </a:ln>
         </p:spPr>
-        <p:style>
-          <a:lnRef idx="0"/>
-          <a:fillRef idx="0"/>
-          <a:effectRef idx="0"/>
-          <a:fontRef idx="minor"/>
-        </p:style>
         <p:txBody>
           <a:bodyPr lIns="0" tIns="0" rIns="0" bIns="0" anchor="t">
             <a:normAutofit/>
           </a:bodyPr>
           <a:p>
-            <a:pPr marL="432000" indent="-324000">
-              <a:lnSpc>
-                <a:spcPct val="100000"/>
+            <a:pPr marL="432000" indent="-324000" algn="l">
+              <a:lnSpc>
+                <a:spcPct val="83000"/>
               </a:lnSpc>
               <a:spcBef>
                 <a:spcPts val="1417"/>
@@ -2276,17 +2292,54 @@
             <a:r>
               <a:rPr lang="en-US" sz="2200" b="0" u="none" strike="noStrike">
                 <a:solidFill>
-                  <a:srgbClr val="000000"/>
-                </a:solidFill>
-                <a:effectLst/>
-                <a:uFillTx/>
-                <a:latin typeface="Calibri"/>
-              </a:rPr>
-              <a:t>86 тестов – 86 успешно</a:t>
+                  <a:srgbClr val="0060FF"/>
+                </a:solidFill>
+                <a:effectLst/>
+                <a:uFillTx/>
+                <a:latin typeface="Calibri"/>
+                <a:hlinkClick r:id="rId1"/>
+              </a:rPr>
+              <a:t>https://github.com/GidRadium/reversi-admin-panel</a:t>
             </a:r>
             <a:endParaRPr lang="en-US" sz="2200" b="0" u="none" strike="noStrike">
               <a:solidFill>
-                <a:srgbClr val="FFFFFF"/>
+                <a:srgbClr val="000000"/>
+              </a:solidFill>
+              <a:effectLst/>
+              <a:uFillTx/>
+              <a:latin typeface="Calibri"/>
+            </a:endParaRPr>
+          </a:p>
+          <a:p>
+            <a:pPr marL="432000" indent="-324000" algn="l">
+              <a:lnSpc>
+                <a:spcPct val="83000"/>
+              </a:lnSpc>
+              <a:spcBef>
+                <a:spcPts val="1417"/>
+              </a:spcBef>
+              <a:buClr>
+                <a:srgbClr val="000000"/>
+              </a:buClr>
+              <a:buSzPct val="45000"/>
+              <a:buFont typeface="Wingdings" charset="2"/>
+              <a:buChar char=""/>
+            </a:pPr>
+            <a:r>
+              <a:rPr lang="en-US" sz="2200" b="0" u="none" strike="noStrike">
+                <a:solidFill>
+                  <a:srgbClr val="0060FF"/>
+                </a:solidFill>
+                <a:effectLst/>
+                <a:uFillTx/>
+                <a:latin typeface="Calibri"/>
+                <a:hlinkClick r:id="rId2"/>
+              </a:rPr>
+              <a:t>https://en.wikipedia.org/wiki/Reversi</a:t>
+            </a:r>
+            <a:endParaRPr lang="en-US" sz="2200" b="0" u="none" strike="noStrike">
+              <a:solidFill>
+                <a:srgbClr val="000000"/>
               </a:solidFill>
               <a:effectLst/>
               <a:uFillTx/>
@@ -2309,7 +2362,7 @@
 </file>
 
 <file path=ppt/slides/slide13.xml><?xml version="1.0" encoding="utf-8"?>
-<p:sld xmlns:a="http://schemas.openxmlformats.org/drawingml/2006/main" xmlns:p="http://schemas.openxmlformats.org/presentationml/2006/main" xmlns:r="http://schemas.openxmlformats.org/officeDocument/2006/relationships" xmlns:p14="http://schemas.microsoft.com/office/powerpoint/2010/main" xmlns:p15="http://schemas.microsoft.com/office/powerpoint/2012/main" xmlns:mc="http://schemas.openxmlformats.org/markup-compatibility/2006">
+<p:sld xmlns:a="http://schemas.openxmlformats.org/drawingml/2006/main" xmlns:p="http://schemas.openxmlformats.org/presentationml/2006/main" xmlns:r="http://schemas.openxmlformats.org/officeDocument/2006/relationships" xmlns:p14="http://schemas.microsoft.com/office/powerpoint/2010/main" xmlns:p15="http://schemas.microsoft.com/office/powerpoint/2012/main" xmlns:mc="http://schemas.openxmlformats.org/markup-compatibility/2006" show="0">
   <p:cSld>
     <p:spTree>
       <p:nvGrpSpPr>
@@ -2327,7 +2380,7 @@
       </p:grpSpPr>
       <p:sp>
         <p:nvSpPr>
-          <p:cNvPr id="55" name="PlaceHolder 1"/>
+          <p:cNvPr id="54" name="PlaceHolder 1"/>
           <p:cNvSpPr>
             <a:spLocks noGrp="1"/>
           </p:cNvSpPr>
@@ -2371,7 +2424,7 @@
                 <a:uFillTx/>
                 <a:latin typeface="Calibri"/>
               </a:rPr>
-              <a:t>Ссылки</a:t>
+              <a:t>База данных</a:t>
             </a:r>
             <a:endParaRPr lang="en-US" sz="4400" b="0" u="none" strike="noStrike">
               <a:solidFill>
@@ -2384,107 +2437,54 @@
           </a:p>
         </p:txBody>
       </p:sp>
-      <p:sp>
-        <p:nvSpPr>
-          <p:cNvPr id="56" name="PlaceHolder 2"/>
-          <p:cNvSpPr>
-            <a:spLocks noGrp="1"/>
-          </p:cNvSpPr>
-          <p:nvPr>
-            <p:ph/>
-          </p:nvPr>
-        </p:nvSpPr>
-        <p:spPr>
-          <a:xfrm>
-            <a:off x="264600" y="1636200"/>
-            <a:ext cx="9071280" cy="3287880"/>
-          </a:xfrm>
-          <a:prstGeom prst="rect">
-            <a:avLst/>
-          </a:prstGeom>
-          <a:noFill/>
-          <a:ln w="0">
-            <a:noFill/>
-          </a:ln>
-        </p:spPr>
-        <p:txBody>
-          <a:bodyPr lIns="0" tIns="0" rIns="0" bIns="0" anchor="t">
-            <a:normAutofit/>
-          </a:bodyPr>
-          <a:p>
-            <a:pPr marL="432000" indent="-324000" algn="l">
-              <a:lnSpc>
-                <a:spcPct val="83000"/>
-              </a:lnSpc>
-              <a:spcBef>
-                <a:spcPts val="1417"/>
-              </a:spcBef>
-              <a:buClr>
-                <a:srgbClr val="000000"/>
-              </a:buClr>
-              <a:buSzPct val="45000"/>
-              <a:buFont typeface="Wingdings" charset="2"/>
-              <a:buChar char=""/>
-            </a:pPr>
-            <a:r>
-              <a:rPr lang="en-US" sz="2200" b="0" u="none" strike="noStrike">
-                <a:solidFill>
-                  <a:srgbClr val="0060FF"/>
-                </a:solidFill>
-                <a:effectLst/>
-                <a:uFillTx/>
-                <a:latin typeface="Calibri"/>
-                <a:hlinkClick r:id="rId1"/>
-              </a:rPr>
-              <a:t>https://github.com/GidRadium/reversi-admin-panel</a:t>
-            </a:r>
-            <a:endParaRPr lang="en-US" sz="2200" b="0" u="none" strike="noStrike">
-              <a:solidFill>
-                <a:srgbClr val="000000"/>
-              </a:solidFill>
-              <a:effectLst/>
-              <a:uFillTx/>
-              <a:latin typeface="Calibri"/>
-            </a:endParaRPr>
-          </a:p>
-          <a:p>
-            <a:pPr marL="432000" indent="-324000" algn="l">
-              <a:lnSpc>
-                <a:spcPct val="83000"/>
-              </a:lnSpc>
-              <a:spcBef>
-                <a:spcPts val="1417"/>
-              </a:spcBef>
-              <a:buClr>
-                <a:srgbClr val="000000"/>
-              </a:buClr>
-              <a:buSzPct val="45000"/>
-              <a:buFont typeface="Wingdings" charset="2"/>
-              <a:buChar char=""/>
-            </a:pPr>
-            <a:r>
-              <a:rPr lang="en-US" sz="2200" b="0" u="none" strike="noStrike">
-                <a:solidFill>
-                  <a:srgbClr val="0060FF"/>
-                </a:solidFill>
-                <a:effectLst/>
-                <a:uFillTx/>
-                <a:latin typeface="Calibri"/>
-                <a:hlinkClick r:id="rId2"/>
-              </a:rPr>
-              <a:t>https://en.wikipedia.org/wiki/Reversi</a:t>
-            </a:r>
-            <a:endParaRPr lang="en-US" sz="2200" b="0" u="none" strike="noStrike">
-              <a:solidFill>
-                <a:srgbClr val="000000"/>
-              </a:solidFill>
-              <a:effectLst/>
-              <a:uFillTx/>
-              <a:latin typeface="Calibri"/>
-            </a:endParaRPr>
-          </a:p>
-        </p:txBody>
-      </p:sp>
+      <p:pic>
+        <p:nvPicPr>
+          <p:cNvPr id="55" name=""/>
+          <p:cNvPicPr/>
+          <p:nvPr/>
+        </p:nvPicPr>
+        <p:blipFill>
+          <a:blip r:embed="rId1"/>
+          <a:stretch/>
+        </p:blipFill>
+        <p:spPr>
+          <a:xfrm>
+            <a:off x="457200" y="1828800"/>
+            <a:ext cx="9463680" cy="2022840"/>
+          </a:xfrm>
+          <a:prstGeom prst="rect">
+            <a:avLst/>
+          </a:prstGeom>
+          <a:noFill/>
+          <a:ln w="38160">
+            <a:noFill/>
+          </a:ln>
+        </p:spPr>
+      </p:pic>
+      <p:pic>
+        <p:nvPicPr>
+          <p:cNvPr id="56" name=""/>
+          <p:cNvPicPr/>
+          <p:nvPr/>
+        </p:nvPicPr>
+        <p:blipFill>
+          <a:blip r:embed="rId2"/>
+          <a:stretch/>
+        </p:blipFill>
+        <p:spPr>
+          <a:xfrm>
+            <a:off x="457200" y="4115520"/>
+            <a:ext cx="9373680" cy="862560"/>
+          </a:xfrm>
+          <a:prstGeom prst="rect">
+            <a:avLst/>
+          </a:prstGeom>
+          <a:noFill/>
+          <a:ln w="38160">
+            <a:noFill/>
+          </a:ln>
+        </p:spPr>
+      </p:pic>
     </p:spTree>
   </p:cSld>
   <mc:AlternateContent>
@@ -2941,19 +2941,18 @@
           <p:cNvPr id="20" name=""/>
           <p:cNvCxnSpPr>
             <a:stCxn id="17" idx="1"/>
-            <a:endCxn id="16" idx="3"/>
+            <a:endCxn id="16" idx="6"/>
           </p:cNvCxnSpPr>
           <p:nvPr/>
         </p:nvCxnSpPr>
         <p:spPr>
           <a:xfrm flipV="1" rot="10800000">
-            <a:off x="1114560" y="3657600"/>
-            <a:ext cx="1629360" cy="486360"/>
-          </a:xfrm>
-          <a:prstGeom prst="bentConnector4">
+            <a:off x="2285280" y="3657240"/>
+            <a:ext cx="458640" cy="1440"/>
+          </a:xfrm>
+          <a:prstGeom prst="bentConnector3">
             <a:avLst>
-              <a:gd name="adj1" fmla="val 14055"/>
-              <a:gd name="adj2" fmla="val 141333"/>
+              <a:gd name="adj1" fmla="val 49960"/>
             </a:avLst>
           </a:prstGeom>
           <a:ln w="38160">
@@ -3129,7 +3128,7 @@
         <p:spPr>
           <a:xfrm>
             <a:off x="504000" y="1326600"/>
-            <a:ext cx="5668560" cy="3287880"/>
+            <a:ext cx="5668560" cy="3703320"/>
           </a:xfrm>
           <a:prstGeom prst="rect">
             <a:avLst/>
@@ -3141,7 +3140,7 @@
         </p:spPr>
         <p:txBody>
           <a:bodyPr lIns="0" tIns="0" rIns="0" bIns="0" anchor="t">
-            <a:normAutofit/>
+            <a:normAutofit lnSpcReduction="9999"/>
           </a:bodyPr>
           <a:p>
             <a:pPr marL="432000" indent="-324000" algn="l">
@@ -3272,7 +3271,7 @@
                 <a:uFillTx/>
                 <a:latin typeface="Calibri"/>
               </a:rPr>
-              <a:t>Постановка фишки – переворот фишек противника по вертикали и/или диагонали, до своей. (хотя-бы 1 перевернуть надо)</a:t>
+              <a:t>Постановка фишки – переворот фишек противника по вертикали и/или диагонали, до своей. (хотя-бы одну перевернуть надо)</a:t>
             </a:r>
             <a:endParaRPr lang="en-US" sz="2200" b="0" u="none" strike="noStrike">
               <a:solidFill>
@@ -3308,6 +3307,41 @@
                 <a:latin typeface="Calibri"/>
               </a:rPr>
               <a:t>Конец – отсутствие доступных ходов обоих игроков.</a:t>
+            </a:r>
+            <a:endParaRPr lang="en-US" sz="2200" b="0" u="none" strike="noStrike">
+              <a:solidFill>
+                <a:srgbClr val="000000"/>
+              </a:solidFill>
+              <a:effectLst/>
+              <a:uFillTx/>
+              <a:latin typeface="Calibri"/>
+            </a:endParaRPr>
+          </a:p>
+          <a:p>
+            <a:pPr marL="432000" indent="-324000" algn="l">
+              <a:lnSpc>
+                <a:spcPct val="83000"/>
+              </a:lnSpc>
+              <a:spcBef>
+                <a:spcPts val="1417"/>
+              </a:spcBef>
+              <a:buClr>
+                <a:srgbClr val="000000"/>
+              </a:buClr>
+              <a:buSzPct val="45000"/>
+              <a:buFont typeface="Wingdings" charset="2"/>
+              <a:buChar char=""/>
+            </a:pPr>
+            <a:r>
+              <a:rPr lang="en-US" sz="2200" b="0" u="none" strike="noStrike">
+                <a:solidFill>
+                  <a:srgbClr val="000000"/>
+                </a:solidFill>
+                <a:effectLst/>
+                <a:uFillTx/>
+                <a:latin typeface="Calibri"/>
+              </a:rPr>
+              <a:t>Результат – выигрывает игрок с наибольшим числом фишек. При равенстве – ничья.</a:t>
             </a:r>
             <a:endParaRPr lang="en-US" sz="2200" b="0" u="none" strike="noStrike">
               <a:solidFill>

</xml_diff>